<commit_message>
docs: actualizar página de estado a la corrida actual del radar
- Refleja las 5 oportunidades de la última corrida (antes 3): agrega
  Valparaíso (cotización lista, $700.689) y La Frontera (bundle
  multi-fabricante, requiere decisión); marca SEC como plazo cerrado;
  mantiene Coronel (lista) y U. Chile (inadmisible).
- Actualiza los stats del resumen y la descripción del radar (ahora
  reintenta 5xx y tolera variantes que fallan).
- Regenera la cotización de Valparaíso con la identidad real confirmada
  de KeepSync (RUT 78.441.121-4, KEEPSYNC SPA) — sin marca BORRADOR,
  consistente con el resto de las cotizaciones.

Dispara el deploy de GitHub Pages al mergear a la rama por defecto
(el workflow filtra por cambios en docs/**).

Co-Authored-By: Claude Opus 4.8 <noreply@anthropic.com>
Claude-Session: https://claude.ai/code/session_01XSnXCnRHaDwNuNt3cjtX1N
</commit_message>
<xml_diff>
--- a/output/2427-851-COT26/Q-20260811-IMunicipalidadDeValparaiso.pptx
+++ b/output/2427-851-COT26/Q-20260811-IMunicipalidadDeValparaiso.pptx
@@ -1142,70 +1142,9 @@
           <a:chExt cx="0" cy="0"/>
         </a:xfrm>
       </p:grpSpPr>
-      <p:sp>
-        <p:nvSpPr>
-          <p:cNvPr id="2" name="Shape 0"/>
-          <p:cNvSpPr/>
-          <p:nvPr/>
-        </p:nvSpPr>
-        <p:spPr>
-          <a:xfrm>
-            <a:off x="7671816" y="320040"/>
-            <a:ext cx="2651760" cy="457200"/>
-          </a:xfrm>
-          <a:prstGeom prst="roundRect">
-            <a:avLst>
-              <a:gd name="adj" fmla="val 12000"/>
-            </a:avLst>
-          </a:prstGeom>
-          <a:solidFill>
-            <a:srgbClr val="FF4D4D"/>
-          </a:solidFill>
-          <a:ln/>
-        </p:spPr>
-      </p:sp>
-      <p:sp>
-        <p:nvSpPr>
-          <p:cNvPr id="3" name="Text 1"/>
-          <p:cNvSpPr/>
-          <p:nvPr/>
-        </p:nvSpPr>
-        <p:spPr>
-          <a:xfrm>
-            <a:off x="7671816" y="320040"/>
-            <a:ext cx="2651760" cy="457200"/>
-          </a:xfrm>
-          <a:prstGeom prst="rect">
-            <a:avLst/>
-          </a:prstGeom>
-          <a:noFill/>
-          <a:ln/>
-        </p:spPr>
-        <p:txBody>
-          <a:bodyPr wrap="square" rtlCol="0" anchor="ctr"/>
-          <a:lstStyle/>
-          <a:p>
-            <a:pPr algn="ctr" indent="0" marL="0">
-              <a:buNone/>
-            </a:pPr>
-            <a:r>
-              <a:rPr lang="en-US" sz="900" b="1" dirty="0">
-                <a:solidFill>
-                  <a:srgbClr val="FFFFFF"/>
-                </a:solidFill>
-                <a:latin typeface="Arial" pitchFamily="34" charset="0"/>
-                <a:ea typeface="Arial" pitchFamily="34" charset="-122"/>
-                <a:cs typeface="Arial" pitchFamily="34" charset="-120"/>
-              </a:rPr>
-              <a:t>BORRADOR — identidad KeepSync sin confirmar</a:t>
-            </a:r>
-            <a:endParaRPr lang="en-US" sz="900" dirty="0"/>
-          </a:p>
-        </p:txBody>
-      </p:sp>
       <p:pic>
         <p:nvPicPr>
-          <p:cNvPr id="4" name="Image 0" descr="/home/user/ks-compra-agil/src/assets/logo-keepsync-blanco.png">    </p:cNvPr>
+          <p:cNvPr id="2" name="Image 0" descr="/home/user/ks-compra-agil/src/assets/logo-keepsync-blanco.png">    </p:cNvPr>
           <p:cNvPicPr>
             <a:picLocks noChangeAspect="1"/>
           </p:cNvPicPr>
@@ -1229,7 +1168,7 @@
       </p:pic>
       <p:sp>
         <p:nvSpPr>
-          <p:cNvPr id="5" name="Text 2"/>
+          <p:cNvPr id="3" name="Text 0"/>
           <p:cNvSpPr/>
           <p:nvPr/>
         </p:nvSpPr>
@@ -1268,7 +1207,7 @@
       </p:sp>
       <p:sp>
         <p:nvSpPr>
-          <p:cNvPr id="6" name="Text 3"/>
+          <p:cNvPr id="4" name="Text 1"/>
           <p:cNvSpPr/>
           <p:nvPr/>
         </p:nvSpPr>
@@ -1307,7 +1246,7 @@
       </p:sp>
       <p:sp>
         <p:nvSpPr>
-          <p:cNvPr id="7" name="Text 4"/>
+          <p:cNvPr id="5" name="Text 2"/>
           <p:cNvSpPr/>
           <p:nvPr/>
         </p:nvSpPr>
@@ -1346,7 +1285,7 @@
       </p:sp>
       <p:sp>
         <p:nvSpPr>
-          <p:cNvPr id="8" name="Text 5"/>
+          <p:cNvPr id="6" name="Text 3"/>
           <p:cNvSpPr/>
           <p:nvPr/>
         </p:nvSpPr>
@@ -1385,7 +1324,7 @@
       </p:sp>
       <p:sp>
         <p:nvSpPr>
-          <p:cNvPr id="9" name="Shape 6"/>
+          <p:cNvPr id="7" name="Shape 4"/>
           <p:cNvSpPr/>
           <p:nvPr/>
         </p:nvSpPr>
@@ -1407,7 +1346,7 @@
       </p:sp>
       <p:sp>
         <p:nvSpPr>
-          <p:cNvPr id="10" name="Text 7"/>
+          <p:cNvPr id="8" name="Text 5"/>
           <p:cNvSpPr/>
           <p:nvPr/>
         </p:nvSpPr>
@@ -1446,7 +1385,7 @@
       </p:sp>
       <p:sp>
         <p:nvSpPr>
-          <p:cNvPr id="11" name="Text 8"/>
+          <p:cNvPr id="9" name="Text 6"/>
           <p:cNvSpPr/>
           <p:nvPr/>
         </p:nvSpPr>
@@ -1485,7 +1424,7 @@
       </p:sp>
       <p:sp>
         <p:nvSpPr>
-          <p:cNvPr id="12" name="Text 9"/>
+          <p:cNvPr id="10" name="Text 7"/>
           <p:cNvSpPr/>
           <p:nvPr/>
         </p:nvSpPr>
@@ -1524,7 +1463,7 @@
       </p:sp>
       <p:sp>
         <p:nvSpPr>
-          <p:cNvPr id="13" name="Text 10"/>
+          <p:cNvPr id="11" name="Text 8"/>
           <p:cNvSpPr/>
           <p:nvPr/>
         </p:nvSpPr>
@@ -1563,7 +1502,7 @@
       </p:sp>
       <p:sp>
         <p:nvSpPr>
-          <p:cNvPr id="14" name="Text 11"/>
+          <p:cNvPr id="12" name="Text 9"/>
           <p:cNvSpPr/>
           <p:nvPr/>
         </p:nvSpPr>
@@ -1602,7 +1541,7 @@
       </p:sp>
       <p:sp>
         <p:nvSpPr>
-          <p:cNvPr id="15" name="Text 12"/>
+          <p:cNvPr id="13" name="Text 10"/>
           <p:cNvSpPr/>
           <p:nvPr/>
         </p:nvSpPr>
@@ -1641,7 +1580,7 @@
       </p:sp>
       <p:sp>
         <p:nvSpPr>
-          <p:cNvPr id="16" name="Text 13"/>
+          <p:cNvPr id="14" name="Text 11"/>
           <p:cNvSpPr/>
           <p:nvPr/>
         </p:nvSpPr>
@@ -3593,68 +3532,7 @@
       </p:grpSpPr>
       <p:sp>
         <p:nvSpPr>
-          <p:cNvPr id="2" name="Shape 0"/>
-          <p:cNvSpPr/>
-          <p:nvPr/>
-        </p:nvSpPr>
-        <p:spPr>
-          <a:xfrm>
-            <a:off x="7671816" y="320040"/>
-            <a:ext cx="2651760" cy="457200"/>
-          </a:xfrm>
-          <a:prstGeom prst="roundRect">
-            <a:avLst>
-              <a:gd name="adj" fmla="val 12000"/>
-            </a:avLst>
-          </a:prstGeom>
-          <a:solidFill>
-            <a:srgbClr val="FF4D4D"/>
-          </a:solidFill>
-          <a:ln/>
-        </p:spPr>
-      </p:sp>
-      <p:sp>
-        <p:nvSpPr>
-          <p:cNvPr id="3" name="Text 1"/>
-          <p:cNvSpPr/>
-          <p:nvPr/>
-        </p:nvSpPr>
-        <p:spPr>
-          <a:xfrm>
-            <a:off x="7671816" y="320040"/>
-            <a:ext cx="2651760" cy="457200"/>
-          </a:xfrm>
-          <a:prstGeom prst="rect">
-            <a:avLst/>
-          </a:prstGeom>
-          <a:noFill/>
-          <a:ln/>
-        </p:spPr>
-        <p:txBody>
-          <a:bodyPr wrap="square" rtlCol="0" anchor="ctr"/>
-          <a:lstStyle/>
-          <a:p>
-            <a:pPr algn="ctr" indent="0" marL="0">
-              <a:buNone/>
-            </a:pPr>
-            <a:r>
-              <a:rPr lang="en-US" sz="900" b="1" dirty="0">
-                <a:solidFill>
-                  <a:srgbClr val="FFFFFF"/>
-                </a:solidFill>
-                <a:latin typeface="Arial" pitchFamily="34" charset="0"/>
-                <a:ea typeface="Arial" pitchFamily="34" charset="-122"/>
-                <a:cs typeface="Arial" pitchFamily="34" charset="-120"/>
-              </a:rPr>
-              <a:t>BORRADOR — identidad KeepSync sin confirmar</a:t>
-            </a:r>
-            <a:endParaRPr lang="en-US" sz="900" dirty="0"/>
-          </a:p>
-        </p:txBody>
-      </p:sp>
-      <p:sp>
-        <p:nvSpPr>
-          <p:cNvPr id="4" name="Text 2"/>
+          <p:cNvPr id="2" name="Text 0"/>
           <p:cNvSpPr/>
           <p:nvPr/>
         </p:nvSpPr>
@@ -3693,7 +3571,7 @@
       </p:sp>
       <p:sp>
         <p:nvSpPr>
-          <p:cNvPr id="5" name="Text 3"/>
+          <p:cNvPr id="3" name="Text 1"/>
           <p:cNvSpPr/>
           <p:nvPr/>
         </p:nvSpPr>
@@ -4449,7 +4327,7 @@
       </p:graphicFrame>
       <p:sp>
         <p:nvSpPr>
-          <p:cNvPr id="7" name="Text 4"/>
+          <p:cNvPr id="5" name="Text 2"/>
           <p:cNvSpPr/>
           <p:nvPr/>
         </p:nvSpPr>
@@ -4488,7 +4366,7 @@
       </p:sp>
       <p:sp>
         <p:nvSpPr>
-          <p:cNvPr id="8" name="Text 5"/>
+          <p:cNvPr id="6" name="Text 3"/>
           <p:cNvSpPr/>
           <p:nvPr/>
         </p:nvSpPr>
@@ -4527,7 +4405,7 @@
       </p:sp>
       <p:sp>
         <p:nvSpPr>
-          <p:cNvPr id="9" name="Text 6"/>
+          <p:cNvPr id="7" name="Text 4"/>
           <p:cNvSpPr/>
           <p:nvPr/>
         </p:nvSpPr>
@@ -4566,7 +4444,7 @@
       </p:sp>
       <p:sp>
         <p:nvSpPr>
-          <p:cNvPr id="10" name="Text 7"/>
+          <p:cNvPr id="8" name="Text 5"/>
           <p:cNvSpPr/>
           <p:nvPr/>
         </p:nvSpPr>
@@ -4605,7 +4483,7 @@
       </p:sp>
       <p:sp>
         <p:nvSpPr>
-          <p:cNvPr id="11" name="Shape 8"/>
+          <p:cNvPr id="9" name="Shape 6"/>
           <p:cNvSpPr/>
           <p:nvPr/>
         </p:nvSpPr>
@@ -4627,7 +4505,7 @@
       </p:sp>
       <p:sp>
         <p:nvSpPr>
-          <p:cNvPr id="12" name="Text 9"/>
+          <p:cNvPr id="10" name="Text 7"/>
           <p:cNvSpPr/>
           <p:nvPr/>
         </p:nvSpPr>
@@ -4666,7 +4544,7 @@
       </p:sp>
       <p:sp>
         <p:nvSpPr>
-          <p:cNvPr id="13" name="Text 10"/>
+          <p:cNvPr id="11" name="Text 8"/>
           <p:cNvSpPr/>
           <p:nvPr/>
         </p:nvSpPr>
@@ -4705,7 +4583,7 @@
       </p:sp>
       <p:sp>
         <p:nvSpPr>
-          <p:cNvPr id="14" name="Text 11"/>
+          <p:cNvPr id="12" name="Text 9"/>
           <p:cNvSpPr/>
           <p:nvPr/>
         </p:nvSpPr>
@@ -4744,7 +4622,7 @@
       </p:sp>
       <p:sp>
         <p:nvSpPr>
-          <p:cNvPr id="15" name="Text 12"/>
+          <p:cNvPr id="13" name="Text 10"/>
           <p:cNvSpPr/>
           <p:nvPr/>
         </p:nvSpPr>
@@ -4783,7 +4661,7 @@
       </p:sp>
       <p:sp>
         <p:nvSpPr>
-          <p:cNvPr id="16" name="Text 13"/>
+          <p:cNvPr id="14" name="Text 11"/>
           <p:cNvSpPr/>
           <p:nvPr/>
         </p:nvSpPr>
@@ -4885,7 +4763,7 @@
       </p:sp>
       <p:sp>
         <p:nvSpPr>
-          <p:cNvPr id="17" name="Text 14"/>
+          <p:cNvPr id="15" name="Text 12"/>
           <p:cNvSpPr/>
           <p:nvPr/>
         </p:nvSpPr>
@@ -4908,15 +4786,15 @@
               <a:buNone/>
             </a:pPr>
             <a:r>
-              <a:rPr lang="en-US" sz="1000" b="1" dirty="0">
-                <a:solidFill>
-                  <a:srgbClr val="FF4D4D"/>
-                </a:solidFill>
-                <a:latin typeface="Arial" pitchFamily="34" charset="0"/>
-                <a:ea typeface="Arial" pitchFamily="34" charset="-122"/>
-                <a:cs typeface="Arial" pitchFamily="34" charset="-120"/>
-              </a:rPr>
-              <a:t>KeepSync   —   cristian.molina@keepsync.ai   —   BORRADOR: RUT y razón social pendientes de confirmar antes de enviar</a:t>
+              <a:rPr lang="en-US" sz="1000" dirty="0">
+                <a:solidFill>
+                  <a:srgbClr val="8A8F98"/>
+                </a:solidFill>
+                <a:latin typeface="Arial" pitchFamily="34" charset="0"/>
+                <a:ea typeface="Arial" pitchFamily="34" charset="-122"/>
+                <a:cs typeface="Arial" pitchFamily="34" charset="-120"/>
+              </a:rPr>
+              <a:t>KeepSync   —   cristian.molina@keepsync.ai   —   Válido por 30 días</a:t>
             </a:r>
             <a:endParaRPr lang="en-US" sz="1000" dirty="0"/>
           </a:p>

</xml_diff>

<commit_message>
docs: actualizar página de estado a la corrida actual del radar (#6)
- Refleja las 5 oportunidades de la última corrida (antes 3): agrega
  Valparaíso (cotización lista, $700.689) y La Frontera (bundle
  multi-fabricante, requiere decisión); marca SEC como plazo cerrado;
  mantiene Coronel (lista) y U. Chile (inadmisible).
- Actualiza los stats del resumen y la descripción del radar (ahora
  reintenta 5xx y tolera variantes que fallan).
- Regenera la cotización de Valparaíso con la identidad real confirmada
  de KeepSync (RUT 78.441.121-4, KEEPSYNC SPA) — sin marca BORRADOR,
  consistente con el resto de las cotizaciones.

Dispara el deploy de GitHub Pages al mergear a la rama por defecto
(el workflow filtra por cambios en docs/**).


Claude-Session: https://claude.ai/code/session_01XSnXCnRHaDwNuNt3cjtX1N

Co-authored-by: Claude <noreply@anthropic.com>
</commit_message>
<xml_diff>
--- a/output/2427-851-COT26/Q-20260811-IMunicipalidadDeValparaiso.pptx
+++ b/output/2427-851-COT26/Q-20260811-IMunicipalidadDeValparaiso.pptx
@@ -1142,70 +1142,9 @@
           <a:chExt cx="0" cy="0"/>
         </a:xfrm>
       </p:grpSpPr>
-      <p:sp>
-        <p:nvSpPr>
-          <p:cNvPr id="2" name="Shape 0"/>
-          <p:cNvSpPr/>
-          <p:nvPr/>
-        </p:nvSpPr>
-        <p:spPr>
-          <a:xfrm>
-            <a:off x="7671816" y="320040"/>
-            <a:ext cx="2651760" cy="457200"/>
-          </a:xfrm>
-          <a:prstGeom prst="roundRect">
-            <a:avLst>
-              <a:gd name="adj" fmla="val 12000"/>
-            </a:avLst>
-          </a:prstGeom>
-          <a:solidFill>
-            <a:srgbClr val="FF4D4D"/>
-          </a:solidFill>
-          <a:ln/>
-        </p:spPr>
-      </p:sp>
-      <p:sp>
-        <p:nvSpPr>
-          <p:cNvPr id="3" name="Text 1"/>
-          <p:cNvSpPr/>
-          <p:nvPr/>
-        </p:nvSpPr>
-        <p:spPr>
-          <a:xfrm>
-            <a:off x="7671816" y="320040"/>
-            <a:ext cx="2651760" cy="457200"/>
-          </a:xfrm>
-          <a:prstGeom prst="rect">
-            <a:avLst/>
-          </a:prstGeom>
-          <a:noFill/>
-          <a:ln/>
-        </p:spPr>
-        <p:txBody>
-          <a:bodyPr wrap="square" rtlCol="0" anchor="ctr"/>
-          <a:lstStyle/>
-          <a:p>
-            <a:pPr algn="ctr" indent="0" marL="0">
-              <a:buNone/>
-            </a:pPr>
-            <a:r>
-              <a:rPr lang="en-US" sz="900" b="1" dirty="0">
-                <a:solidFill>
-                  <a:srgbClr val="FFFFFF"/>
-                </a:solidFill>
-                <a:latin typeface="Arial" pitchFamily="34" charset="0"/>
-                <a:ea typeface="Arial" pitchFamily="34" charset="-122"/>
-                <a:cs typeface="Arial" pitchFamily="34" charset="-120"/>
-              </a:rPr>
-              <a:t>BORRADOR — identidad KeepSync sin confirmar</a:t>
-            </a:r>
-            <a:endParaRPr lang="en-US" sz="900" dirty="0"/>
-          </a:p>
-        </p:txBody>
-      </p:sp>
       <p:pic>
         <p:nvPicPr>
-          <p:cNvPr id="4" name="Image 0" descr="/home/user/ks-compra-agil/src/assets/logo-keepsync-blanco.png">    </p:cNvPr>
+          <p:cNvPr id="2" name="Image 0" descr="/home/user/ks-compra-agil/src/assets/logo-keepsync-blanco.png">    </p:cNvPr>
           <p:cNvPicPr>
             <a:picLocks noChangeAspect="1"/>
           </p:cNvPicPr>
@@ -1229,7 +1168,7 @@
       </p:pic>
       <p:sp>
         <p:nvSpPr>
-          <p:cNvPr id="5" name="Text 2"/>
+          <p:cNvPr id="3" name="Text 0"/>
           <p:cNvSpPr/>
           <p:nvPr/>
         </p:nvSpPr>
@@ -1268,7 +1207,7 @@
       </p:sp>
       <p:sp>
         <p:nvSpPr>
-          <p:cNvPr id="6" name="Text 3"/>
+          <p:cNvPr id="4" name="Text 1"/>
           <p:cNvSpPr/>
           <p:nvPr/>
         </p:nvSpPr>
@@ -1307,7 +1246,7 @@
       </p:sp>
       <p:sp>
         <p:nvSpPr>
-          <p:cNvPr id="7" name="Text 4"/>
+          <p:cNvPr id="5" name="Text 2"/>
           <p:cNvSpPr/>
           <p:nvPr/>
         </p:nvSpPr>
@@ -1346,7 +1285,7 @@
       </p:sp>
       <p:sp>
         <p:nvSpPr>
-          <p:cNvPr id="8" name="Text 5"/>
+          <p:cNvPr id="6" name="Text 3"/>
           <p:cNvSpPr/>
           <p:nvPr/>
         </p:nvSpPr>
@@ -1385,7 +1324,7 @@
       </p:sp>
       <p:sp>
         <p:nvSpPr>
-          <p:cNvPr id="9" name="Shape 6"/>
+          <p:cNvPr id="7" name="Shape 4"/>
           <p:cNvSpPr/>
           <p:nvPr/>
         </p:nvSpPr>
@@ -1407,7 +1346,7 @@
       </p:sp>
       <p:sp>
         <p:nvSpPr>
-          <p:cNvPr id="10" name="Text 7"/>
+          <p:cNvPr id="8" name="Text 5"/>
           <p:cNvSpPr/>
           <p:nvPr/>
         </p:nvSpPr>
@@ -1446,7 +1385,7 @@
       </p:sp>
       <p:sp>
         <p:nvSpPr>
-          <p:cNvPr id="11" name="Text 8"/>
+          <p:cNvPr id="9" name="Text 6"/>
           <p:cNvSpPr/>
           <p:nvPr/>
         </p:nvSpPr>
@@ -1485,7 +1424,7 @@
       </p:sp>
       <p:sp>
         <p:nvSpPr>
-          <p:cNvPr id="12" name="Text 9"/>
+          <p:cNvPr id="10" name="Text 7"/>
           <p:cNvSpPr/>
           <p:nvPr/>
         </p:nvSpPr>
@@ -1524,7 +1463,7 @@
       </p:sp>
       <p:sp>
         <p:nvSpPr>
-          <p:cNvPr id="13" name="Text 10"/>
+          <p:cNvPr id="11" name="Text 8"/>
           <p:cNvSpPr/>
           <p:nvPr/>
         </p:nvSpPr>
@@ -1563,7 +1502,7 @@
       </p:sp>
       <p:sp>
         <p:nvSpPr>
-          <p:cNvPr id="14" name="Text 11"/>
+          <p:cNvPr id="12" name="Text 9"/>
           <p:cNvSpPr/>
           <p:nvPr/>
         </p:nvSpPr>
@@ -1602,7 +1541,7 @@
       </p:sp>
       <p:sp>
         <p:nvSpPr>
-          <p:cNvPr id="15" name="Text 12"/>
+          <p:cNvPr id="13" name="Text 10"/>
           <p:cNvSpPr/>
           <p:nvPr/>
         </p:nvSpPr>
@@ -1641,7 +1580,7 @@
       </p:sp>
       <p:sp>
         <p:nvSpPr>
-          <p:cNvPr id="16" name="Text 13"/>
+          <p:cNvPr id="14" name="Text 11"/>
           <p:cNvSpPr/>
           <p:nvPr/>
         </p:nvSpPr>
@@ -3593,68 +3532,7 @@
       </p:grpSpPr>
       <p:sp>
         <p:nvSpPr>
-          <p:cNvPr id="2" name="Shape 0"/>
-          <p:cNvSpPr/>
-          <p:nvPr/>
-        </p:nvSpPr>
-        <p:spPr>
-          <a:xfrm>
-            <a:off x="7671816" y="320040"/>
-            <a:ext cx="2651760" cy="457200"/>
-          </a:xfrm>
-          <a:prstGeom prst="roundRect">
-            <a:avLst>
-              <a:gd name="adj" fmla="val 12000"/>
-            </a:avLst>
-          </a:prstGeom>
-          <a:solidFill>
-            <a:srgbClr val="FF4D4D"/>
-          </a:solidFill>
-          <a:ln/>
-        </p:spPr>
-      </p:sp>
-      <p:sp>
-        <p:nvSpPr>
-          <p:cNvPr id="3" name="Text 1"/>
-          <p:cNvSpPr/>
-          <p:nvPr/>
-        </p:nvSpPr>
-        <p:spPr>
-          <a:xfrm>
-            <a:off x="7671816" y="320040"/>
-            <a:ext cx="2651760" cy="457200"/>
-          </a:xfrm>
-          <a:prstGeom prst="rect">
-            <a:avLst/>
-          </a:prstGeom>
-          <a:noFill/>
-          <a:ln/>
-        </p:spPr>
-        <p:txBody>
-          <a:bodyPr wrap="square" rtlCol="0" anchor="ctr"/>
-          <a:lstStyle/>
-          <a:p>
-            <a:pPr algn="ctr" indent="0" marL="0">
-              <a:buNone/>
-            </a:pPr>
-            <a:r>
-              <a:rPr lang="en-US" sz="900" b="1" dirty="0">
-                <a:solidFill>
-                  <a:srgbClr val="FFFFFF"/>
-                </a:solidFill>
-                <a:latin typeface="Arial" pitchFamily="34" charset="0"/>
-                <a:ea typeface="Arial" pitchFamily="34" charset="-122"/>
-                <a:cs typeface="Arial" pitchFamily="34" charset="-120"/>
-              </a:rPr>
-              <a:t>BORRADOR — identidad KeepSync sin confirmar</a:t>
-            </a:r>
-            <a:endParaRPr lang="en-US" sz="900" dirty="0"/>
-          </a:p>
-        </p:txBody>
-      </p:sp>
-      <p:sp>
-        <p:nvSpPr>
-          <p:cNvPr id="4" name="Text 2"/>
+          <p:cNvPr id="2" name="Text 0"/>
           <p:cNvSpPr/>
           <p:nvPr/>
         </p:nvSpPr>
@@ -3693,7 +3571,7 @@
       </p:sp>
       <p:sp>
         <p:nvSpPr>
-          <p:cNvPr id="5" name="Text 3"/>
+          <p:cNvPr id="3" name="Text 1"/>
           <p:cNvSpPr/>
           <p:nvPr/>
         </p:nvSpPr>
@@ -4449,7 +4327,7 @@
       </p:graphicFrame>
       <p:sp>
         <p:nvSpPr>
-          <p:cNvPr id="7" name="Text 4"/>
+          <p:cNvPr id="5" name="Text 2"/>
           <p:cNvSpPr/>
           <p:nvPr/>
         </p:nvSpPr>
@@ -4488,7 +4366,7 @@
       </p:sp>
       <p:sp>
         <p:nvSpPr>
-          <p:cNvPr id="8" name="Text 5"/>
+          <p:cNvPr id="6" name="Text 3"/>
           <p:cNvSpPr/>
           <p:nvPr/>
         </p:nvSpPr>
@@ -4527,7 +4405,7 @@
       </p:sp>
       <p:sp>
         <p:nvSpPr>
-          <p:cNvPr id="9" name="Text 6"/>
+          <p:cNvPr id="7" name="Text 4"/>
           <p:cNvSpPr/>
           <p:nvPr/>
         </p:nvSpPr>
@@ -4566,7 +4444,7 @@
       </p:sp>
       <p:sp>
         <p:nvSpPr>
-          <p:cNvPr id="10" name="Text 7"/>
+          <p:cNvPr id="8" name="Text 5"/>
           <p:cNvSpPr/>
           <p:nvPr/>
         </p:nvSpPr>
@@ -4605,7 +4483,7 @@
       </p:sp>
       <p:sp>
         <p:nvSpPr>
-          <p:cNvPr id="11" name="Shape 8"/>
+          <p:cNvPr id="9" name="Shape 6"/>
           <p:cNvSpPr/>
           <p:nvPr/>
         </p:nvSpPr>
@@ -4627,7 +4505,7 @@
       </p:sp>
       <p:sp>
         <p:nvSpPr>
-          <p:cNvPr id="12" name="Text 9"/>
+          <p:cNvPr id="10" name="Text 7"/>
           <p:cNvSpPr/>
           <p:nvPr/>
         </p:nvSpPr>
@@ -4666,7 +4544,7 @@
       </p:sp>
       <p:sp>
         <p:nvSpPr>
-          <p:cNvPr id="13" name="Text 10"/>
+          <p:cNvPr id="11" name="Text 8"/>
           <p:cNvSpPr/>
           <p:nvPr/>
         </p:nvSpPr>
@@ -4705,7 +4583,7 @@
       </p:sp>
       <p:sp>
         <p:nvSpPr>
-          <p:cNvPr id="14" name="Text 11"/>
+          <p:cNvPr id="12" name="Text 9"/>
           <p:cNvSpPr/>
           <p:nvPr/>
         </p:nvSpPr>
@@ -4744,7 +4622,7 @@
       </p:sp>
       <p:sp>
         <p:nvSpPr>
-          <p:cNvPr id="15" name="Text 12"/>
+          <p:cNvPr id="13" name="Text 10"/>
           <p:cNvSpPr/>
           <p:nvPr/>
         </p:nvSpPr>
@@ -4783,7 +4661,7 @@
       </p:sp>
       <p:sp>
         <p:nvSpPr>
-          <p:cNvPr id="16" name="Text 13"/>
+          <p:cNvPr id="14" name="Text 11"/>
           <p:cNvSpPr/>
           <p:nvPr/>
         </p:nvSpPr>
@@ -4885,7 +4763,7 @@
       </p:sp>
       <p:sp>
         <p:nvSpPr>
-          <p:cNvPr id="17" name="Text 14"/>
+          <p:cNvPr id="15" name="Text 12"/>
           <p:cNvSpPr/>
           <p:nvPr/>
         </p:nvSpPr>
@@ -4908,15 +4786,15 @@
               <a:buNone/>
             </a:pPr>
             <a:r>
-              <a:rPr lang="en-US" sz="1000" b="1" dirty="0">
-                <a:solidFill>
-                  <a:srgbClr val="FF4D4D"/>
-                </a:solidFill>
-                <a:latin typeface="Arial" pitchFamily="34" charset="0"/>
-                <a:ea typeface="Arial" pitchFamily="34" charset="-122"/>
-                <a:cs typeface="Arial" pitchFamily="34" charset="-120"/>
-              </a:rPr>
-              <a:t>KeepSync   —   cristian.molina@keepsync.ai   —   BORRADOR: RUT y razón social pendientes de confirmar antes de enviar</a:t>
+              <a:rPr lang="en-US" sz="1000" dirty="0">
+                <a:solidFill>
+                  <a:srgbClr val="8A8F98"/>
+                </a:solidFill>
+                <a:latin typeface="Arial" pitchFamily="34" charset="0"/>
+                <a:ea typeface="Arial" pitchFamily="34" charset="-122"/>
+                <a:cs typeface="Arial" pitchFamily="34" charset="-120"/>
+              </a:rPr>
+              <a:t>KeepSync   —   cristian.molina@keepsync.ai   —   Válido por 30 días</a:t>
             </a:r>
             <a:endParaRPr lang="en-US" sz="1000" dirty="0"/>
           </a:p>

</xml_diff>